<commit_message>
Subcategory- working with create feature
</commit_message>
<xml_diff>
--- a/.lessons/56 Category, Subcategory and Child Category Setup/9 Subcategory- working with create feature/1.pptx
+++ b/.lessons/56 Category, Subcategory and Child Category Setup/9 Subcategory- working with create feature/1.pptx
@@ -6,8 +6,14 @@
   </p:sldMasterIdLst>
   <p:sldIdLst>
     <p:sldId id="413" r:id="rId2"/>
-    <p:sldId id="414" r:id="rId3"/>
-    <p:sldId id="400" r:id="rId4"/>
+    <p:sldId id="415" r:id="rId3"/>
+    <p:sldId id="416" r:id="rId4"/>
+    <p:sldId id="417" r:id="rId5"/>
+    <p:sldId id="418" r:id="rId6"/>
+    <p:sldId id="414" r:id="rId7"/>
+    <p:sldId id="400" r:id="rId8"/>
+    <p:sldId id="419" r:id="rId9"/>
+    <p:sldId id="420" r:id="rId10"/>
   </p:sldIdLst>
   <p:sldSz cx="12192000" cy="6858000"/>
   <p:notesSz cx="6858000" cy="9144000"/>
@@ -261,7 +267,7 @@
           <a:p>
             <a:fld id="{3E102D2E-813C-461C-9963-687A650C48C0}" type="datetimeFigureOut">
               <a:rPr lang="en-US" smtClean="0"/>
-              <a:t>6/26/2025</a:t>
+              <a:t>8/20/2025</a:t>
             </a:fld>
             <a:endParaRPr lang="en-US"/>
           </a:p>
@@ -459,7 +465,7 @@
           <a:p>
             <a:fld id="{3E102D2E-813C-461C-9963-687A650C48C0}" type="datetimeFigureOut">
               <a:rPr lang="en-US" smtClean="0"/>
-              <a:t>6/26/2025</a:t>
+              <a:t>8/20/2025</a:t>
             </a:fld>
             <a:endParaRPr lang="en-US"/>
           </a:p>
@@ -667,7 +673,7 @@
           <a:p>
             <a:fld id="{3E102D2E-813C-461C-9963-687A650C48C0}" type="datetimeFigureOut">
               <a:rPr lang="en-US" smtClean="0"/>
-              <a:t>6/26/2025</a:t>
+              <a:t>8/20/2025</a:t>
             </a:fld>
             <a:endParaRPr lang="en-US"/>
           </a:p>
@@ -865,7 +871,7 @@
           <a:p>
             <a:fld id="{3E102D2E-813C-461C-9963-687A650C48C0}" type="datetimeFigureOut">
               <a:rPr lang="en-US" smtClean="0"/>
-              <a:t>6/26/2025</a:t>
+              <a:t>8/20/2025</a:t>
             </a:fld>
             <a:endParaRPr lang="en-US"/>
           </a:p>
@@ -1140,7 +1146,7 @@
           <a:p>
             <a:fld id="{3E102D2E-813C-461C-9963-687A650C48C0}" type="datetimeFigureOut">
               <a:rPr lang="en-US" smtClean="0"/>
-              <a:t>6/26/2025</a:t>
+              <a:t>8/20/2025</a:t>
             </a:fld>
             <a:endParaRPr lang="en-US"/>
           </a:p>
@@ -1405,7 +1411,7 @@
           <a:p>
             <a:fld id="{3E102D2E-813C-461C-9963-687A650C48C0}" type="datetimeFigureOut">
               <a:rPr lang="en-US" smtClean="0"/>
-              <a:t>6/26/2025</a:t>
+              <a:t>8/20/2025</a:t>
             </a:fld>
             <a:endParaRPr lang="en-US"/>
           </a:p>
@@ -1817,7 +1823,7 @@
           <a:p>
             <a:fld id="{3E102D2E-813C-461C-9963-687A650C48C0}" type="datetimeFigureOut">
               <a:rPr lang="en-US" smtClean="0"/>
-              <a:t>6/26/2025</a:t>
+              <a:t>8/20/2025</a:t>
             </a:fld>
             <a:endParaRPr lang="en-US"/>
           </a:p>
@@ -1958,7 +1964,7 @@
           <a:p>
             <a:fld id="{3E102D2E-813C-461C-9963-687A650C48C0}" type="datetimeFigureOut">
               <a:rPr lang="en-US" smtClean="0"/>
-              <a:t>6/26/2025</a:t>
+              <a:t>8/20/2025</a:t>
             </a:fld>
             <a:endParaRPr lang="en-US"/>
           </a:p>
@@ -2071,7 +2077,7 @@
           <a:p>
             <a:fld id="{3E102D2E-813C-461C-9963-687A650C48C0}" type="datetimeFigureOut">
               <a:rPr lang="en-US" smtClean="0"/>
-              <a:t>6/26/2025</a:t>
+              <a:t>8/20/2025</a:t>
             </a:fld>
             <a:endParaRPr lang="en-US"/>
           </a:p>
@@ -2382,7 +2388,7 @@
           <a:p>
             <a:fld id="{3E102D2E-813C-461C-9963-687A650C48C0}" type="datetimeFigureOut">
               <a:rPr lang="en-US" smtClean="0"/>
-              <a:t>6/26/2025</a:t>
+              <a:t>8/20/2025</a:t>
             </a:fld>
             <a:endParaRPr lang="en-US"/>
           </a:p>
@@ -2670,7 +2676,7 @@
           <a:p>
             <a:fld id="{3E102D2E-813C-461C-9963-687A650C48C0}" type="datetimeFigureOut">
               <a:rPr lang="en-US" smtClean="0"/>
-              <a:t>6/26/2025</a:t>
+              <a:t>8/20/2025</a:t>
             </a:fld>
             <a:endParaRPr lang="en-US"/>
           </a:p>
@@ -2911,7 +2917,7 @@
           <a:p>
             <a:fld id="{3E102D2E-813C-461C-9963-687A650C48C0}" type="datetimeFigureOut">
               <a:rPr lang="en-US" smtClean="0"/>
-              <a:t>6/26/2025</a:t>
+              <a:t>8/20/2025</a:t>
             </a:fld>
             <a:endParaRPr lang="en-US"/>
           </a:p>
@@ -3348,8 +3354,8 @@
         </p:nvSpPr>
         <p:spPr>
           <a:xfrm>
-            <a:off x="217714" y="255046"/>
-            <a:ext cx="11756571" cy="355354"/>
+            <a:off x="217714" y="88791"/>
+            <a:ext cx="11756571" cy="1630703"/>
           </a:xfrm>
           <a:prstGeom prst="rect">
             <a:avLst/>
@@ -3364,12 +3370,25 @@
           <a:p>
             <a:pPr>
               <a:lnSpc>
-                <a:spcPct val="150000"/>
+                <a:spcPct val="200000"/>
               </a:lnSpc>
               <a:buNone/>
             </a:pPr>
             <a:r>
-              <a:rPr kumimoji="0" lang="en-US" altLang="en-US" sz="1300" b="0" i="0" u="none" strike="noStrike" cap="none" normalizeH="0" baseline="0">
+              <a:rPr kumimoji="0" lang="az-Latn-AZ" altLang="en-US" sz="1300" b="1" i="0" u="none" strike="noStrike" cap="none" normalizeH="0" baseline="0">
+                <a:ln>
+                  <a:noFill/>
+                </a:ln>
+                <a:solidFill>
+                  <a:srgbClr val="FF0000"/>
+                </a:solidFill>
+                <a:effectLst/>
+                <a:latin typeface="Arial" panose="020B0604020202020204" pitchFamily="34" charset="0"/>
+              </a:rPr>
+              <a:t>1) </a:t>
+            </a:r>
+            <a:r>
+              <a:rPr kumimoji="0" lang="az-Latn-AZ" altLang="en-US" sz="1300" b="0" i="0" u="none" strike="noStrike" cap="none" normalizeH="0" baseline="0">
                 <a:ln>
                   <a:noFill/>
                 </a:ln>
@@ -3379,11 +3398,197 @@
                 <a:effectLst/>
                 <a:latin typeface="Arial" panose="020B0604020202020204" pitchFamily="34" charset="0"/>
               </a:rPr>
-              <a:t>.</a:t>
-            </a:r>
-          </a:p>
-        </p:txBody>
-      </p:sp>
+              <a:t>`</a:t>
+            </a:r>
+            <a:r>
+              <a:rPr lang="en-US" altLang="en-US" sz="1300" b="1">
+                <a:latin typeface="Arial" panose="020B0604020202020204" pitchFamily="34" charset="0"/>
+              </a:rPr>
+              <a:t>resources\views\admin\sub-category\</a:t>
+            </a:r>
+            <a:r>
+              <a:rPr lang="en-US" altLang="en-US" sz="1300" b="1" u="sng">
+                <a:latin typeface="Arial" panose="020B0604020202020204" pitchFamily="34" charset="0"/>
+              </a:rPr>
+              <a:t>create.blade.php</a:t>
+            </a:r>
+            <a:r>
+              <a:rPr kumimoji="0" lang="az-Latn-AZ" altLang="en-US" sz="1300" b="0" i="0" u="none" strike="noStrike" cap="none" normalizeH="0" baseline="0">
+                <a:ln>
+                  <a:noFill/>
+                </a:ln>
+                <a:solidFill>
+                  <a:schemeClr val="tx1"/>
+                </a:solidFill>
+                <a:effectLst/>
+                <a:latin typeface="Arial" panose="020B0604020202020204" pitchFamily="34" charset="0"/>
+              </a:rPr>
+              <a:t>` şbalonuna keçmək üçün, `</a:t>
+            </a:r>
+            <a:r>
+              <a:rPr lang="en-US" altLang="en-US" sz="1300" b="1">
+                <a:latin typeface="Arial" panose="020B0604020202020204" pitchFamily="34" charset="0"/>
+              </a:rPr>
+              <a:t>resources\views\admin\sub-category\</a:t>
+            </a:r>
+            <a:r>
+              <a:rPr lang="en-US" altLang="en-US" sz="1300" b="1" u="sng">
+                <a:latin typeface="Arial" panose="020B0604020202020204" pitchFamily="34" charset="0"/>
+              </a:rPr>
+              <a:t>index.blade.php</a:t>
+            </a:r>
+            <a:r>
+              <a:rPr kumimoji="0" lang="az-Latn-AZ" altLang="en-US" sz="1300" b="0" i="0" u="none" strike="noStrike" cap="none" normalizeH="0" baseline="0">
+                <a:ln>
+                  <a:noFill/>
+                </a:ln>
+                <a:solidFill>
+                  <a:schemeClr val="tx1"/>
+                </a:solidFill>
+                <a:effectLst/>
+                <a:latin typeface="Arial" panose="020B0604020202020204" pitchFamily="34" charset="0"/>
+              </a:rPr>
+              <a:t>` faylındakı </a:t>
+            </a:r>
+            <a:r>
+              <a:rPr kumimoji="0" lang="en-US" altLang="en-US" sz="1300" b="1" i="0" u="none" strike="noStrike" cap="none" normalizeH="0" baseline="0">
+                <a:ln>
+                  <a:noFill/>
+                </a:ln>
+                <a:solidFill>
+                  <a:schemeClr val="tx1"/>
+                </a:solidFill>
+                <a:effectLst/>
+                <a:latin typeface="Arial" panose="020B0604020202020204" pitchFamily="34" charset="0"/>
+              </a:rPr>
+              <a:t>&lt;a&gt; </a:t>
+            </a:r>
+            <a:r>
+              <a:rPr lang="az-Latn-AZ" altLang="en-US" sz="1300">
+                <a:latin typeface="Arial" panose="020B0604020202020204" pitchFamily="34" charset="0"/>
+              </a:rPr>
+              <a:t>elementinə `</a:t>
+            </a:r>
+            <a:r>
+              <a:rPr lang="az-Latn-AZ" altLang="en-US" sz="1300" b="1">
+                <a:latin typeface="Arial" panose="020B0604020202020204" pitchFamily="34" charset="0"/>
+              </a:rPr>
+              <a:t>admin.sub-category.create</a:t>
+            </a:r>
+            <a:r>
+              <a:rPr lang="az-Latn-AZ" altLang="en-US" sz="1300">
+                <a:latin typeface="Arial" panose="020B0604020202020204" pitchFamily="34" charset="0"/>
+              </a:rPr>
+              <a:t>` route -unu əlavə edirik. </a:t>
+            </a:r>
+          </a:p>
+          <a:p>
+            <a:pPr>
+              <a:lnSpc>
+                <a:spcPct val="200000"/>
+              </a:lnSpc>
+              <a:buNone/>
+            </a:pPr>
+            <a:endParaRPr kumimoji="0" lang="az-Latn-AZ" altLang="en-US" sz="1300" b="0" i="0" u="none" strike="noStrike" cap="none" normalizeH="0" baseline="0">
+              <a:ln>
+                <a:noFill/>
+              </a:ln>
+              <a:solidFill>
+                <a:schemeClr val="tx1"/>
+              </a:solidFill>
+              <a:effectLst/>
+              <a:latin typeface="Arial" panose="020B0604020202020204" pitchFamily="34" charset="0"/>
+            </a:endParaRPr>
+          </a:p>
+          <a:p>
+            <a:pPr>
+              <a:lnSpc>
+                <a:spcPct val="200000"/>
+              </a:lnSpc>
+              <a:buNone/>
+            </a:pPr>
+            <a:r>
+              <a:rPr lang="az-Latn-AZ" altLang="en-US" sz="1300" b="1">
+                <a:solidFill>
+                  <a:srgbClr val="FF0000"/>
+                </a:solidFill>
+                <a:latin typeface="Arial" panose="020B0604020202020204" pitchFamily="34" charset="0"/>
+              </a:rPr>
+              <a:t>2) </a:t>
+            </a:r>
+            <a:r>
+              <a:rPr lang="az-Latn-AZ" altLang="en-US" sz="1300">
+                <a:latin typeface="Arial" panose="020B0604020202020204" pitchFamily="34" charset="0"/>
+              </a:rPr>
+              <a:t>Statusu </a:t>
+            </a:r>
+            <a:r>
+              <a:rPr lang="az-Latn-AZ" altLang="en-US" sz="1300" b="1">
+                <a:latin typeface="Arial" panose="020B0604020202020204" pitchFamily="34" charset="0"/>
+              </a:rPr>
+              <a:t>qapadıb-açmaq</a:t>
+            </a:r>
+            <a:r>
+              <a:rPr lang="az-Latn-AZ" altLang="en-US" sz="1300">
+                <a:latin typeface="Arial" panose="020B0604020202020204" pitchFamily="34" charset="0"/>
+              </a:rPr>
+              <a:t> üçün istifadə edilən </a:t>
+            </a:r>
+            <a:r>
+              <a:rPr lang="az-Latn-AZ" altLang="en-US" sz="1300" b="1">
+                <a:latin typeface="Arial" panose="020B0604020202020204" pitchFamily="34" charset="0"/>
+              </a:rPr>
+              <a:t>route</a:t>
+            </a:r>
+            <a:r>
+              <a:rPr lang="az-Latn-AZ" altLang="en-US" sz="1300">
+                <a:latin typeface="Arial" panose="020B0604020202020204" pitchFamily="34" charset="0"/>
+              </a:rPr>
+              <a:t> adınıda əlavə edirik.</a:t>
+            </a:r>
+            <a:endParaRPr kumimoji="0" lang="en-US" altLang="en-US" sz="1300" b="0" i="0" u="none" strike="noStrike" cap="none" normalizeH="0" baseline="0">
+              <a:ln>
+                <a:noFill/>
+              </a:ln>
+              <a:solidFill>
+                <a:schemeClr val="tx1"/>
+              </a:solidFill>
+              <a:effectLst/>
+              <a:latin typeface="Arial" panose="020B0604020202020204" pitchFamily="34" charset="0"/>
+            </a:endParaRPr>
+          </a:p>
+        </p:txBody>
+      </p:sp>
+      <p:pic>
+        <p:nvPicPr>
+          <p:cNvPr id="4" name="Picture 3">
+            <a:extLst>
+              <a:ext uri="{FF2B5EF4-FFF2-40B4-BE49-F238E27FC236}">
+                <a16:creationId xmlns:a16="http://schemas.microsoft.com/office/drawing/2014/main" id="{8FDF1364-C712-3E88-8F12-EEBD487D06E1}"/>
+              </a:ext>
+            </a:extLst>
+          </p:cNvPr>
+          <p:cNvPicPr>
+            <a:picLocks noChangeAspect="1"/>
+          </p:cNvPicPr>
+          <p:nvPr/>
+        </p:nvPicPr>
+        <p:blipFill>
+          <a:blip r:embed="rId2"/>
+          <a:stretch>
+            <a:fillRect/>
+          </a:stretch>
+        </p:blipFill>
+        <p:spPr>
+          <a:xfrm>
+            <a:off x="4611428" y="1985818"/>
+            <a:ext cx="7580571" cy="4872182"/>
+          </a:xfrm>
+          <a:prstGeom prst="rect">
+            <a:avLst/>
+          </a:prstGeom>
+        </p:spPr>
+      </p:pic>
     </p:spTree>
     <p:extLst>
       <p:ext uri="{BB962C8B-B14F-4D97-AF65-F5344CB8AC3E}">
@@ -3398,6 +3603,689 @@
 </file>
 
 <file path=ppt/slides/slide2.xml><?xml version="1.0" encoding="utf-8"?>
+<p:sld xmlns:a="http://schemas.openxmlformats.org/drawingml/2006/main" xmlns:r="http://schemas.openxmlformats.org/officeDocument/2006/relationships" xmlns:p="http://schemas.openxmlformats.org/presentationml/2006/main">
+  <p:cSld>
+    <p:spTree>
+      <p:nvGrpSpPr>
+        <p:cNvPr id="1" name="">
+          <a:extLst>
+            <a:ext uri="{FF2B5EF4-FFF2-40B4-BE49-F238E27FC236}">
+              <a16:creationId xmlns:a16="http://schemas.microsoft.com/office/drawing/2014/main" id="{BB9895C8-8D39-2C01-4BA7-D04CB7F807AA}"/>
+            </a:ext>
+          </a:extLst>
+        </p:cNvPr>
+        <p:cNvGrpSpPr/>
+        <p:nvPr/>
+      </p:nvGrpSpPr>
+      <p:grpSpPr>
+        <a:xfrm>
+          <a:off x="0" y="0"/>
+          <a:ext cx="0" cy="0"/>
+          <a:chOff x="0" y="0"/>
+          <a:chExt cx="0" cy="0"/>
+        </a:xfrm>
+      </p:grpSpPr>
+      <p:sp>
+        <p:nvSpPr>
+          <p:cNvPr id="3" name="TextBox 2">
+            <a:extLst>
+              <a:ext uri="{FF2B5EF4-FFF2-40B4-BE49-F238E27FC236}">
+                <a16:creationId xmlns:a16="http://schemas.microsoft.com/office/drawing/2014/main" id="{89EF418B-BDD2-B4ED-4ECD-2BE78D53D359}"/>
+              </a:ext>
+            </a:extLst>
+          </p:cNvPr>
+          <p:cNvSpPr txBox="1"/>
+          <p:nvPr/>
+        </p:nvSpPr>
+        <p:spPr>
+          <a:xfrm>
+            <a:off x="217715" y="255046"/>
+            <a:ext cx="7199086" cy="655436"/>
+          </a:xfrm>
+          <a:prstGeom prst="rect">
+            <a:avLst/>
+          </a:prstGeom>
+          <a:noFill/>
+        </p:spPr>
+        <p:txBody>
+          <a:bodyPr wrap="square">
+            <a:spAutoFit/>
+          </a:bodyPr>
+          <a:lstStyle/>
+          <a:p>
+            <a:pPr>
+              <a:lnSpc>
+                <a:spcPct val="150000"/>
+              </a:lnSpc>
+              <a:buNone/>
+            </a:pPr>
+            <a:r>
+              <a:rPr lang="en-US" altLang="en-US" sz="1300">
+                <a:latin typeface="Arial" panose="020B0604020202020204" pitchFamily="34" charset="0"/>
+              </a:rPr>
+              <a:t>`</a:t>
+            </a:r>
+            <a:r>
+              <a:rPr lang="en-US" altLang="en-US" sz="1300" b="1">
+                <a:latin typeface="Arial" panose="020B0604020202020204" pitchFamily="34" charset="0"/>
+              </a:rPr>
+              <a:t>resources\views\admin\sub-category\create.blade.php</a:t>
+            </a:r>
+            <a:r>
+              <a:rPr lang="en-US" altLang="en-US" sz="1300">
+                <a:latin typeface="Arial" panose="020B0604020202020204" pitchFamily="34" charset="0"/>
+              </a:rPr>
+              <a:t>` </a:t>
+            </a:r>
+            <a:r>
+              <a:rPr lang="az-Latn-AZ" altLang="en-US" sz="1300">
+                <a:latin typeface="Arial" panose="020B0604020202020204" pitchFamily="34" charset="0"/>
+              </a:rPr>
+              <a:t>şablonuna, </a:t>
+            </a:r>
+            <a:r>
+              <a:rPr lang="az-Latn-AZ" altLang="en-US" sz="1300" b="1">
+                <a:latin typeface="Arial" panose="020B0604020202020204" pitchFamily="34" charset="0"/>
+              </a:rPr>
+              <a:t>Category</a:t>
+            </a:r>
+            <a:r>
+              <a:rPr lang="az-Latn-AZ" altLang="en-US" sz="1300">
+                <a:latin typeface="Arial" panose="020B0604020202020204" pitchFamily="34" charset="0"/>
+              </a:rPr>
+              <a:t> -ləri göndəririk.</a:t>
+            </a:r>
+            <a:endParaRPr kumimoji="0" lang="en-US" altLang="en-US" sz="1300" b="0" i="0" u="none" strike="noStrike" cap="none" normalizeH="0" baseline="0">
+              <a:ln>
+                <a:noFill/>
+              </a:ln>
+              <a:solidFill>
+                <a:schemeClr val="tx1"/>
+              </a:solidFill>
+              <a:effectLst/>
+              <a:latin typeface="Arial" panose="020B0604020202020204" pitchFamily="34" charset="0"/>
+            </a:endParaRPr>
+          </a:p>
+        </p:txBody>
+      </p:sp>
+      <p:pic>
+        <p:nvPicPr>
+          <p:cNvPr id="4" name="Picture 3">
+            <a:extLst>
+              <a:ext uri="{FF2B5EF4-FFF2-40B4-BE49-F238E27FC236}">
+                <a16:creationId xmlns:a16="http://schemas.microsoft.com/office/drawing/2014/main" id="{D51B32CC-98C6-03D8-17BF-C09F4F071F9F}"/>
+              </a:ext>
+            </a:extLst>
+          </p:cNvPr>
+          <p:cNvPicPr>
+            <a:picLocks noChangeAspect="1"/>
+          </p:cNvPicPr>
+          <p:nvPr/>
+        </p:nvPicPr>
+        <p:blipFill>
+          <a:blip r:embed="rId2"/>
+          <a:stretch>
+            <a:fillRect/>
+          </a:stretch>
+        </p:blipFill>
+        <p:spPr>
+          <a:xfrm>
+            <a:off x="7549877" y="0"/>
+            <a:ext cx="4642123" cy="6858000"/>
+          </a:xfrm>
+          <a:prstGeom prst="rect">
+            <a:avLst/>
+          </a:prstGeom>
+        </p:spPr>
+      </p:pic>
+    </p:spTree>
+    <p:extLst>
+      <p:ext uri="{BB962C8B-B14F-4D97-AF65-F5344CB8AC3E}">
+        <p14:creationId xmlns:p14="http://schemas.microsoft.com/office/powerpoint/2010/main" val="1149584215"/>
+      </p:ext>
+    </p:extLst>
+  </p:cSld>
+  <p:clrMapOvr>
+    <a:masterClrMapping/>
+  </p:clrMapOvr>
+</p:sld>
+</file>
+
+<file path=ppt/slides/slide3.xml><?xml version="1.0" encoding="utf-8"?>
+<p:sld xmlns:a="http://schemas.openxmlformats.org/drawingml/2006/main" xmlns:r="http://schemas.openxmlformats.org/officeDocument/2006/relationships" xmlns:p="http://schemas.openxmlformats.org/presentationml/2006/main">
+  <p:cSld>
+    <p:spTree>
+      <p:nvGrpSpPr>
+        <p:cNvPr id="1" name="">
+          <a:extLst>
+            <a:ext uri="{FF2B5EF4-FFF2-40B4-BE49-F238E27FC236}">
+              <a16:creationId xmlns:a16="http://schemas.microsoft.com/office/drawing/2014/main" id="{C70B7E37-383D-B079-B218-7C1E0970011B}"/>
+            </a:ext>
+          </a:extLst>
+        </p:cNvPr>
+        <p:cNvGrpSpPr/>
+        <p:nvPr/>
+      </p:nvGrpSpPr>
+      <p:grpSpPr>
+        <a:xfrm>
+          <a:off x="0" y="0"/>
+          <a:ext cx="0" cy="0"/>
+          <a:chOff x="0" y="0"/>
+          <a:chExt cx="0" cy="0"/>
+        </a:xfrm>
+      </p:grpSpPr>
+      <p:sp>
+        <p:nvSpPr>
+          <p:cNvPr id="3" name="TextBox 2">
+            <a:extLst>
+              <a:ext uri="{FF2B5EF4-FFF2-40B4-BE49-F238E27FC236}">
+                <a16:creationId xmlns:a16="http://schemas.microsoft.com/office/drawing/2014/main" id="{D1892480-76E7-5001-9FBC-074EE59D2730}"/>
+              </a:ext>
+            </a:extLst>
+          </p:cNvPr>
+          <p:cNvSpPr txBox="1"/>
+          <p:nvPr/>
+        </p:nvSpPr>
+        <p:spPr>
+          <a:xfrm>
+            <a:off x="217715" y="255046"/>
+            <a:ext cx="4843812" cy="1555682"/>
+          </a:xfrm>
+          <a:prstGeom prst="rect">
+            <a:avLst/>
+          </a:prstGeom>
+          <a:noFill/>
+        </p:spPr>
+        <p:txBody>
+          <a:bodyPr wrap="square">
+            <a:spAutoFit/>
+          </a:bodyPr>
+          <a:lstStyle/>
+          <a:p>
+            <a:pPr marL="342900" indent="-342900">
+              <a:lnSpc>
+                <a:spcPct val="150000"/>
+              </a:lnSpc>
+              <a:buAutoNum type="arabicParenR"/>
+            </a:pPr>
+            <a:r>
+              <a:rPr lang="az-Latn-AZ" altLang="en-US" sz="1300">
+                <a:latin typeface="Arial" panose="020B0604020202020204" pitchFamily="34" charset="0"/>
+              </a:rPr>
+              <a:t>Kateqoriləri əlavə edirik</a:t>
+            </a:r>
+          </a:p>
+          <a:p>
+            <a:pPr marL="342900" indent="-342900">
+              <a:lnSpc>
+                <a:spcPct val="150000"/>
+              </a:lnSpc>
+              <a:buAutoNum type="arabicParenR"/>
+            </a:pPr>
+            <a:endParaRPr kumimoji="0" lang="az-Latn-AZ" altLang="en-US" sz="1300" b="0" i="0" u="none" strike="noStrike" cap="none" normalizeH="0" baseline="0">
+              <a:ln>
+                <a:noFill/>
+              </a:ln>
+              <a:solidFill>
+                <a:schemeClr val="tx1"/>
+              </a:solidFill>
+              <a:effectLst/>
+              <a:latin typeface="Arial" panose="020B0604020202020204" pitchFamily="34" charset="0"/>
+            </a:endParaRPr>
+          </a:p>
+          <a:p>
+            <a:pPr marL="342900" indent="-342900">
+              <a:lnSpc>
+                <a:spcPct val="150000"/>
+              </a:lnSpc>
+              <a:buAutoNum type="arabicParenR"/>
+            </a:pPr>
+            <a:r>
+              <a:rPr lang="az-Latn-AZ" altLang="en-US" sz="1300">
+                <a:latin typeface="Arial" panose="020B0604020202020204" pitchFamily="34" charset="0"/>
+              </a:rPr>
+              <a:t>Sub sözlərini əlavə edirik</a:t>
+            </a:r>
+          </a:p>
+          <a:p>
+            <a:pPr marL="342900" indent="-342900">
+              <a:lnSpc>
+                <a:spcPct val="150000"/>
+              </a:lnSpc>
+              <a:buAutoNum type="arabicParenR"/>
+            </a:pPr>
+            <a:endParaRPr kumimoji="0" lang="az-Latn-AZ" altLang="en-US" sz="1300" b="0" i="0" u="none" strike="noStrike" cap="none" normalizeH="0" baseline="0">
+              <a:ln>
+                <a:noFill/>
+              </a:ln>
+              <a:solidFill>
+                <a:schemeClr val="tx1"/>
+              </a:solidFill>
+              <a:effectLst/>
+              <a:latin typeface="Arial" panose="020B0604020202020204" pitchFamily="34" charset="0"/>
+            </a:endParaRPr>
+          </a:p>
+          <a:p>
+            <a:pPr marL="342900" indent="-342900">
+              <a:lnSpc>
+                <a:spcPct val="150000"/>
+              </a:lnSpc>
+              <a:buAutoNum type="arabicParenR"/>
+            </a:pPr>
+            <a:r>
+              <a:rPr lang="az-Latn-AZ" altLang="en-US" sz="1300">
+                <a:latin typeface="Arial" panose="020B0604020202020204" pitchFamily="34" charset="0"/>
+              </a:rPr>
+              <a:t>Form elementinə route əlavə edirik</a:t>
+            </a:r>
+            <a:endParaRPr kumimoji="0" lang="en-US" altLang="en-US" sz="1300" b="0" i="0" u="none" strike="noStrike" cap="none" normalizeH="0" baseline="0">
+              <a:ln>
+                <a:noFill/>
+              </a:ln>
+              <a:solidFill>
+                <a:schemeClr val="tx1"/>
+              </a:solidFill>
+              <a:effectLst/>
+              <a:latin typeface="Arial" panose="020B0604020202020204" pitchFamily="34" charset="0"/>
+            </a:endParaRPr>
+          </a:p>
+        </p:txBody>
+      </p:sp>
+      <p:pic>
+        <p:nvPicPr>
+          <p:cNvPr id="6" name="Picture 5">
+            <a:extLst>
+              <a:ext uri="{FF2B5EF4-FFF2-40B4-BE49-F238E27FC236}">
+                <a16:creationId xmlns:a16="http://schemas.microsoft.com/office/drawing/2014/main" id="{DA9A184E-DF35-DD35-657C-8A74BA169142}"/>
+              </a:ext>
+            </a:extLst>
+          </p:cNvPr>
+          <p:cNvPicPr>
+            <a:picLocks noChangeAspect="1"/>
+          </p:cNvPicPr>
+          <p:nvPr/>
+        </p:nvPicPr>
+        <p:blipFill>
+          <a:blip r:embed="rId2"/>
+          <a:stretch>
+            <a:fillRect/>
+          </a:stretch>
+        </p:blipFill>
+        <p:spPr>
+          <a:xfrm>
+            <a:off x="5232829" y="0"/>
+            <a:ext cx="6959171" cy="6858000"/>
+          </a:xfrm>
+          <a:prstGeom prst="rect">
+            <a:avLst/>
+          </a:prstGeom>
+        </p:spPr>
+      </p:pic>
+    </p:spTree>
+    <p:extLst>
+      <p:ext uri="{BB962C8B-B14F-4D97-AF65-F5344CB8AC3E}">
+        <p14:creationId xmlns:p14="http://schemas.microsoft.com/office/powerpoint/2010/main" val="1459551183"/>
+      </p:ext>
+    </p:extLst>
+  </p:cSld>
+  <p:clrMapOvr>
+    <a:masterClrMapping/>
+  </p:clrMapOvr>
+</p:sld>
+</file>
+
+<file path=ppt/slides/slide4.xml><?xml version="1.0" encoding="utf-8"?>
+<p:sld xmlns:a="http://schemas.openxmlformats.org/drawingml/2006/main" xmlns:r="http://schemas.openxmlformats.org/officeDocument/2006/relationships" xmlns:p="http://schemas.openxmlformats.org/presentationml/2006/main">
+  <p:cSld>
+    <p:spTree>
+      <p:nvGrpSpPr>
+        <p:cNvPr id="1" name="">
+          <a:extLst>
+            <a:ext uri="{FF2B5EF4-FFF2-40B4-BE49-F238E27FC236}">
+              <a16:creationId xmlns:a16="http://schemas.microsoft.com/office/drawing/2014/main" id="{BBFEEAC6-C49F-E0E6-831B-81D09002632B}"/>
+            </a:ext>
+          </a:extLst>
+        </p:cNvPr>
+        <p:cNvGrpSpPr/>
+        <p:nvPr/>
+      </p:nvGrpSpPr>
+      <p:grpSpPr>
+        <a:xfrm>
+          <a:off x="0" y="0"/>
+          <a:ext cx="0" cy="0"/>
+          <a:chOff x="0" y="0"/>
+          <a:chExt cx="0" cy="0"/>
+        </a:xfrm>
+      </p:grpSpPr>
+      <p:sp>
+        <p:nvSpPr>
+          <p:cNvPr id="3" name="TextBox 2">
+            <a:extLst>
+              <a:ext uri="{FF2B5EF4-FFF2-40B4-BE49-F238E27FC236}">
+                <a16:creationId xmlns:a16="http://schemas.microsoft.com/office/drawing/2014/main" id="{48CB150F-022F-50BF-EADE-C51788497078}"/>
+              </a:ext>
+            </a:extLst>
+          </p:cNvPr>
+          <p:cNvSpPr txBox="1"/>
+          <p:nvPr/>
+        </p:nvSpPr>
+        <p:spPr>
+          <a:xfrm>
+            <a:off x="217714" y="255046"/>
+            <a:ext cx="11756571" cy="830484"/>
+          </a:xfrm>
+          <a:prstGeom prst="rect">
+            <a:avLst/>
+          </a:prstGeom>
+          <a:noFill/>
+        </p:spPr>
+        <p:txBody>
+          <a:bodyPr wrap="square">
+            <a:spAutoFit/>
+          </a:bodyPr>
+          <a:lstStyle/>
+          <a:p>
+            <a:pPr>
+              <a:lnSpc>
+                <a:spcPct val="200000"/>
+              </a:lnSpc>
+              <a:buNone/>
+            </a:pPr>
+            <a:r>
+              <a:rPr lang="az-Latn-AZ" altLang="en-US" sz="1300" b="1">
+                <a:latin typeface="Arial" panose="020B0604020202020204" pitchFamily="34" charset="0"/>
+              </a:rPr>
+              <a:t>form</a:t>
+            </a:r>
+            <a:r>
+              <a:rPr lang="az-Latn-AZ" altLang="en-US" sz="1300">
+                <a:latin typeface="Arial" panose="020B0604020202020204" pitchFamily="34" charset="0"/>
+              </a:rPr>
+              <a:t> elementi </a:t>
+            </a:r>
+            <a:r>
+              <a:rPr lang="az-Latn-AZ" altLang="en-US" sz="1300" b="1">
+                <a:latin typeface="Arial" panose="020B0604020202020204" pitchFamily="34" charset="0"/>
+              </a:rPr>
+              <a:t>submit</a:t>
+            </a:r>
+            <a:r>
+              <a:rPr lang="az-Latn-AZ" altLang="en-US" sz="1300">
+                <a:latin typeface="Arial" panose="020B0604020202020204" pitchFamily="34" charset="0"/>
+              </a:rPr>
+              <a:t> edildikdə, `</a:t>
+            </a:r>
+            <a:r>
+              <a:rPr lang="az-Latn-AZ" altLang="en-US" sz="1300" b="1">
+                <a:latin typeface="Arial" panose="020B0604020202020204" pitchFamily="34" charset="0"/>
+              </a:rPr>
+              <a:t>route('admin.sub-category.store’)</a:t>
+            </a:r>
+            <a:r>
+              <a:rPr lang="az-Latn-AZ" altLang="en-US" sz="1300">
+                <a:latin typeface="Arial" panose="020B0604020202020204" pitchFamily="34" charset="0"/>
+              </a:rPr>
+              <a:t>` adlı </a:t>
+            </a:r>
+            <a:r>
+              <a:rPr lang="az-Latn-AZ" altLang="en-US" sz="1300" b="1">
+                <a:latin typeface="Arial" panose="020B0604020202020204" pitchFamily="34" charset="0"/>
+              </a:rPr>
+              <a:t>route</a:t>
+            </a:r>
+            <a:r>
+              <a:rPr lang="az-Latn-AZ" altLang="en-US" sz="1300">
+                <a:latin typeface="Arial" panose="020B0604020202020204" pitchFamily="34" charset="0"/>
+              </a:rPr>
+              <a:t> çağrılacaq və </a:t>
+            </a:r>
+          </a:p>
+          <a:p>
+            <a:pPr>
+              <a:lnSpc>
+                <a:spcPct val="200000"/>
+              </a:lnSpc>
+              <a:buNone/>
+            </a:pPr>
+            <a:r>
+              <a:rPr kumimoji="0" lang="az-Latn-AZ" altLang="en-US" sz="1300" b="1" i="0" u="none" strike="noStrike" cap="none" normalizeH="0" baseline="0">
+                <a:ln>
+                  <a:noFill/>
+                </a:ln>
+                <a:solidFill>
+                  <a:schemeClr val="tx1"/>
+                </a:solidFill>
+                <a:effectLst/>
+                <a:latin typeface="Arial" panose="020B0604020202020204" pitchFamily="34" charset="0"/>
+              </a:rPr>
+              <a:t>datalar</a:t>
+            </a:r>
+            <a:r>
+              <a:rPr kumimoji="0" lang="az-Latn-AZ" altLang="en-US" sz="1300" b="0" i="0" u="none" strike="noStrike" cap="none" normalizeH="0" baseline="0">
+                <a:ln>
+                  <a:noFill/>
+                </a:ln>
+                <a:solidFill>
+                  <a:schemeClr val="tx1"/>
+                </a:solidFill>
+                <a:effectLst/>
+                <a:latin typeface="Arial" panose="020B0604020202020204" pitchFamily="34" charset="0"/>
+              </a:rPr>
+              <a:t> verilənlər bazasında `</a:t>
+            </a:r>
+            <a:r>
+              <a:rPr kumimoji="0" lang="az-Latn-AZ" altLang="en-US" sz="1300" b="1" i="0" u="none" strike="noStrike" cap="none" normalizeH="0" baseline="0">
+                <a:ln>
+                  <a:noFill/>
+                </a:ln>
+                <a:solidFill>
+                  <a:schemeClr val="tx1"/>
+                </a:solidFill>
+                <a:effectLst/>
+                <a:latin typeface="Arial" panose="020B0604020202020204" pitchFamily="34" charset="0"/>
+              </a:rPr>
+              <a:t>sub_categories</a:t>
+            </a:r>
+            <a:r>
+              <a:rPr kumimoji="0" lang="az-Latn-AZ" altLang="en-US" sz="1300" b="0" i="0" u="none" strike="noStrike" cap="none" normalizeH="0" baseline="0">
+                <a:ln>
+                  <a:noFill/>
+                </a:ln>
+                <a:solidFill>
+                  <a:schemeClr val="tx1"/>
+                </a:solidFill>
+                <a:effectLst/>
+                <a:latin typeface="Arial" panose="020B0604020202020204" pitchFamily="34" charset="0"/>
+              </a:rPr>
+              <a:t>` cədvəlinə yazılacaq.</a:t>
+            </a:r>
+            <a:endParaRPr kumimoji="0" lang="en-US" altLang="en-US" sz="1300" b="0" i="0" u="none" strike="noStrike" cap="none" normalizeH="0" baseline="0">
+              <a:ln>
+                <a:noFill/>
+              </a:ln>
+              <a:solidFill>
+                <a:schemeClr val="tx1"/>
+              </a:solidFill>
+              <a:effectLst/>
+              <a:latin typeface="Arial" panose="020B0604020202020204" pitchFamily="34" charset="0"/>
+            </a:endParaRPr>
+          </a:p>
+        </p:txBody>
+      </p:sp>
+      <p:pic>
+        <p:nvPicPr>
+          <p:cNvPr id="4" name="Picture 3">
+            <a:extLst>
+              <a:ext uri="{FF2B5EF4-FFF2-40B4-BE49-F238E27FC236}">
+                <a16:creationId xmlns:a16="http://schemas.microsoft.com/office/drawing/2014/main" id="{A6A7831D-4E62-C01B-CE23-36C1367387A9}"/>
+              </a:ext>
+            </a:extLst>
+          </p:cNvPr>
+          <p:cNvPicPr>
+            <a:picLocks noChangeAspect="1"/>
+          </p:cNvPicPr>
+          <p:nvPr/>
+        </p:nvPicPr>
+        <p:blipFill>
+          <a:blip r:embed="rId2"/>
+          <a:stretch>
+            <a:fillRect/>
+          </a:stretch>
+        </p:blipFill>
+        <p:spPr>
+          <a:xfrm>
+            <a:off x="7455243" y="0"/>
+            <a:ext cx="4736757" cy="6858000"/>
+          </a:xfrm>
+          <a:prstGeom prst="rect">
+            <a:avLst/>
+          </a:prstGeom>
+        </p:spPr>
+      </p:pic>
+    </p:spTree>
+    <p:extLst>
+      <p:ext uri="{BB962C8B-B14F-4D97-AF65-F5344CB8AC3E}">
+        <p14:creationId xmlns:p14="http://schemas.microsoft.com/office/powerpoint/2010/main" val="708844236"/>
+      </p:ext>
+    </p:extLst>
+  </p:cSld>
+  <p:clrMapOvr>
+    <a:masterClrMapping/>
+  </p:clrMapOvr>
+</p:sld>
+</file>
+
+<file path=ppt/slides/slide5.xml><?xml version="1.0" encoding="utf-8"?>
+<p:sld xmlns:a="http://schemas.openxmlformats.org/drawingml/2006/main" xmlns:r="http://schemas.openxmlformats.org/officeDocument/2006/relationships" xmlns:p="http://schemas.openxmlformats.org/presentationml/2006/main">
+  <p:cSld>
+    <p:spTree>
+      <p:nvGrpSpPr>
+        <p:cNvPr id="1" name="">
+          <a:extLst>
+            <a:ext uri="{FF2B5EF4-FFF2-40B4-BE49-F238E27FC236}">
+              <a16:creationId xmlns:a16="http://schemas.microsoft.com/office/drawing/2014/main" id="{AF359B3E-CF95-731A-1412-00AE7DDF84D0}"/>
+            </a:ext>
+          </a:extLst>
+        </p:cNvPr>
+        <p:cNvGrpSpPr/>
+        <p:nvPr/>
+      </p:nvGrpSpPr>
+      <p:grpSpPr>
+        <a:xfrm>
+          <a:off x="0" y="0"/>
+          <a:ext cx="0" cy="0"/>
+          <a:chOff x="0" y="0"/>
+          <a:chExt cx="0" cy="0"/>
+        </a:xfrm>
+      </p:grpSpPr>
+      <p:sp>
+        <p:nvSpPr>
+          <p:cNvPr id="3" name="TextBox 2">
+            <a:extLst>
+              <a:ext uri="{FF2B5EF4-FFF2-40B4-BE49-F238E27FC236}">
+                <a16:creationId xmlns:a16="http://schemas.microsoft.com/office/drawing/2014/main" id="{3A21E54C-D673-009C-CEF6-E4579B418FAA}"/>
+              </a:ext>
+            </a:extLst>
+          </p:cNvPr>
+          <p:cNvSpPr txBox="1"/>
+          <p:nvPr/>
+        </p:nvSpPr>
+        <p:spPr>
+          <a:xfrm>
+            <a:off x="217714" y="255046"/>
+            <a:ext cx="11756571" cy="355354"/>
+          </a:xfrm>
+          <a:prstGeom prst="rect">
+            <a:avLst/>
+          </a:prstGeom>
+          <a:noFill/>
+        </p:spPr>
+        <p:txBody>
+          <a:bodyPr wrap="square">
+            <a:spAutoFit/>
+          </a:bodyPr>
+          <a:lstStyle/>
+          <a:p>
+            <a:pPr>
+              <a:lnSpc>
+                <a:spcPct val="150000"/>
+              </a:lnSpc>
+              <a:buNone/>
+            </a:pPr>
+            <a:r>
+              <a:rPr kumimoji="0" lang="en-US" altLang="en-US" sz="1300" b="0" i="0" u="none" strike="noStrike" cap="none" normalizeH="0" baseline="0">
+                <a:ln>
+                  <a:noFill/>
+                </a:ln>
+                <a:solidFill>
+                  <a:schemeClr val="tx1"/>
+                </a:solidFill>
+                <a:effectLst/>
+                <a:latin typeface="Arial" panose="020B0604020202020204" pitchFamily="34" charset="0"/>
+              </a:rPr>
+              <a:t>.</a:t>
+            </a:r>
+          </a:p>
+        </p:txBody>
+      </p:sp>
+      <p:pic>
+        <p:nvPicPr>
+          <p:cNvPr id="4" name="Picture 3">
+            <a:extLst>
+              <a:ext uri="{FF2B5EF4-FFF2-40B4-BE49-F238E27FC236}">
+                <a16:creationId xmlns:a16="http://schemas.microsoft.com/office/drawing/2014/main" id="{6433028E-727B-02D6-2F60-3AED47934F6D}"/>
+              </a:ext>
+            </a:extLst>
+          </p:cNvPr>
+          <p:cNvPicPr>
+            <a:picLocks noChangeAspect="1"/>
+          </p:cNvPicPr>
+          <p:nvPr/>
+        </p:nvPicPr>
+        <p:blipFill>
+          <a:blip r:embed="rId2"/>
+          <a:stretch>
+            <a:fillRect/>
+          </a:stretch>
+        </p:blipFill>
+        <p:spPr>
+          <a:xfrm>
+            <a:off x="0" y="1199842"/>
+            <a:ext cx="12192000" cy="4458316"/>
+          </a:xfrm>
+          <a:prstGeom prst="rect">
+            <a:avLst/>
+          </a:prstGeom>
+          <a:ln w="38100" cap="sq">
+            <a:solidFill>
+              <a:srgbClr val="000000"/>
+            </a:solidFill>
+            <a:prstDash val="solid"/>
+            <a:miter lim="800000"/>
+          </a:ln>
+          <a:effectLst>
+            <a:outerShdw blurRad="50800" dist="38100" dir="2700000" algn="tl" rotWithShape="0">
+              <a:srgbClr val="000000">
+                <a:alpha val="43000"/>
+              </a:srgbClr>
+            </a:outerShdw>
+          </a:effectLst>
+        </p:spPr>
+      </p:pic>
+    </p:spTree>
+    <p:extLst>
+      <p:ext uri="{BB962C8B-B14F-4D97-AF65-F5344CB8AC3E}">
+        <p14:creationId xmlns:p14="http://schemas.microsoft.com/office/powerpoint/2010/main" val="3285982496"/>
+      </p:ext>
+    </p:extLst>
+  </p:cSld>
+  <p:clrMapOvr>
+    <a:masterClrMapping/>
+  </p:clrMapOvr>
+</p:sld>
+</file>
+
+<file path=ppt/slides/slide6.xml><?xml version="1.0" encoding="utf-8"?>
 <p:sld xmlns:a="http://schemas.openxmlformats.org/drawingml/2006/main" xmlns:r="http://schemas.openxmlformats.org/officeDocument/2006/relationships" xmlns:p="http://schemas.openxmlformats.org/presentationml/2006/main">
   <p:cSld>
     <p:spTree>
@@ -3470,6 +4358,50 @@
           </a:p>
         </p:txBody>
       </p:sp>
+      <p:pic>
+        <p:nvPicPr>
+          <p:cNvPr id="4" name="Picture 3">
+            <a:extLst>
+              <a:ext uri="{FF2B5EF4-FFF2-40B4-BE49-F238E27FC236}">
+                <a16:creationId xmlns:a16="http://schemas.microsoft.com/office/drawing/2014/main" id="{DA582382-1E99-8C1B-85D2-09200AC09C94}"/>
+              </a:ext>
+            </a:extLst>
+          </p:cNvPr>
+          <p:cNvPicPr>
+            <a:picLocks noChangeAspect="1"/>
+          </p:cNvPicPr>
+          <p:nvPr/>
+        </p:nvPicPr>
+        <p:blipFill>
+          <a:blip r:embed="rId2"/>
+          <a:stretch>
+            <a:fillRect/>
+          </a:stretch>
+        </p:blipFill>
+        <p:spPr>
+          <a:xfrm>
+            <a:off x="0" y="1611953"/>
+            <a:ext cx="12192000" cy="3634093"/>
+          </a:xfrm>
+          <a:prstGeom prst="rect">
+            <a:avLst/>
+          </a:prstGeom>
+          <a:ln w="38100" cap="sq">
+            <a:solidFill>
+              <a:srgbClr val="000000"/>
+            </a:solidFill>
+            <a:prstDash val="solid"/>
+            <a:miter lim="800000"/>
+          </a:ln>
+          <a:effectLst>
+            <a:outerShdw blurRad="50800" dist="38100" dir="2700000" algn="tl" rotWithShape="0">
+              <a:srgbClr val="000000">
+                <a:alpha val="43000"/>
+              </a:srgbClr>
+            </a:outerShdw>
+          </a:effectLst>
+        </p:spPr>
+      </p:pic>
     </p:spTree>
     <p:extLst>
       <p:ext uri="{BB962C8B-B14F-4D97-AF65-F5344CB8AC3E}">
@@ -3483,7 +4415,7 @@
 </p:sld>
 </file>
 
-<file path=ppt/slides/slide3.xml><?xml version="1.0" encoding="utf-8"?>
+<file path=ppt/slides/slide7.xml><?xml version="1.0" encoding="utf-8"?>
 <p:sld xmlns:a="http://schemas.openxmlformats.org/drawingml/2006/main" xmlns:r="http://schemas.openxmlformats.org/officeDocument/2006/relationships" xmlns:p="http://schemas.openxmlformats.org/presentationml/2006/main">
   <p:cSld>
     <p:spTree>
@@ -3556,10 +4488,226 @@
           </a:p>
         </p:txBody>
       </p:sp>
+      <p:pic>
+        <p:nvPicPr>
+          <p:cNvPr id="4" name="Picture 3">
+            <a:extLst>
+              <a:ext uri="{FF2B5EF4-FFF2-40B4-BE49-F238E27FC236}">
+                <a16:creationId xmlns:a16="http://schemas.microsoft.com/office/drawing/2014/main" id="{D9308402-E540-797B-199D-19F1D2EEBFD5}"/>
+              </a:ext>
+            </a:extLst>
+          </p:cNvPr>
+          <p:cNvPicPr>
+            <a:picLocks noChangeAspect="1"/>
+          </p:cNvPicPr>
+          <p:nvPr/>
+        </p:nvPicPr>
+        <p:blipFill>
+          <a:blip r:embed="rId2"/>
+          <a:stretch>
+            <a:fillRect/>
+          </a:stretch>
+        </p:blipFill>
+        <p:spPr>
+          <a:xfrm>
+            <a:off x="618360" y="1809524"/>
+            <a:ext cx="10955279" cy="3238952"/>
+          </a:xfrm>
+          <a:prstGeom prst="rect">
+            <a:avLst/>
+          </a:prstGeom>
+          <a:ln w="38100" cap="sq">
+            <a:solidFill>
+              <a:srgbClr val="000000"/>
+            </a:solidFill>
+            <a:prstDash val="solid"/>
+            <a:miter lim="800000"/>
+          </a:ln>
+          <a:effectLst>
+            <a:outerShdw blurRad="50800" dist="38100" dir="2700000" algn="tl" rotWithShape="0">
+              <a:srgbClr val="000000">
+                <a:alpha val="43000"/>
+              </a:srgbClr>
+            </a:outerShdw>
+          </a:effectLst>
+        </p:spPr>
+      </p:pic>
     </p:spTree>
     <p:extLst>
       <p:ext uri="{BB962C8B-B14F-4D97-AF65-F5344CB8AC3E}">
         <p14:creationId xmlns:p14="http://schemas.microsoft.com/office/powerpoint/2010/main" val="3095838342"/>
+      </p:ext>
+    </p:extLst>
+  </p:cSld>
+  <p:clrMapOvr>
+    <a:masterClrMapping/>
+  </p:clrMapOvr>
+</p:sld>
+</file>
+
+<file path=ppt/slides/slide8.xml><?xml version="1.0" encoding="utf-8"?>
+<p:sld xmlns:a="http://schemas.openxmlformats.org/drawingml/2006/main" xmlns:r="http://schemas.openxmlformats.org/officeDocument/2006/relationships" xmlns:p="http://schemas.openxmlformats.org/presentationml/2006/main">
+  <p:cSld>
+    <p:spTree>
+      <p:nvGrpSpPr>
+        <p:cNvPr id="1" name="">
+          <a:extLst>
+            <a:ext uri="{FF2B5EF4-FFF2-40B4-BE49-F238E27FC236}">
+              <a16:creationId xmlns:a16="http://schemas.microsoft.com/office/drawing/2014/main" id="{6D77F1BF-34E9-9191-3612-C63EDBBCAD4B}"/>
+            </a:ext>
+          </a:extLst>
+        </p:cNvPr>
+        <p:cNvGrpSpPr/>
+        <p:nvPr/>
+      </p:nvGrpSpPr>
+      <p:grpSpPr>
+        <a:xfrm>
+          <a:off x="0" y="0"/>
+          <a:ext cx="0" cy="0"/>
+          <a:chOff x="0" y="0"/>
+          <a:chExt cx="0" cy="0"/>
+        </a:xfrm>
+      </p:grpSpPr>
+      <p:sp>
+        <p:nvSpPr>
+          <p:cNvPr id="3" name="TextBox 2">
+            <a:extLst>
+              <a:ext uri="{FF2B5EF4-FFF2-40B4-BE49-F238E27FC236}">
+                <a16:creationId xmlns:a16="http://schemas.microsoft.com/office/drawing/2014/main" id="{13F19235-EE7F-F940-2FA5-EA34F4A74233}"/>
+              </a:ext>
+            </a:extLst>
+          </p:cNvPr>
+          <p:cNvSpPr txBox="1"/>
+          <p:nvPr/>
+        </p:nvSpPr>
+        <p:spPr>
+          <a:xfrm>
+            <a:off x="217714" y="255046"/>
+            <a:ext cx="11756571" cy="355354"/>
+          </a:xfrm>
+          <a:prstGeom prst="rect">
+            <a:avLst/>
+          </a:prstGeom>
+          <a:noFill/>
+        </p:spPr>
+        <p:txBody>
+          <a:bodyPr wrap="square">
+            <a:spAutoFit/>
+          </a:bodyPr>
+          <a:lstStyle/>
+          <a:p>
+            <a:pPr>
+              <a:lnSpc>
+                <a:spcPct val="150000"/>
+              </a:lnSpc>
+              <a:buNone/>
+            </a:pPr>
+            <a:r>
+              <a:rPr kumimoji="0" lang="en-US" altLang="en-US" sz="1300" b="0" i="0" u="none" strike="noStrike" cap="none" normalizeH="0" baseline="0">
+                <a:ln>
+                  <a:noFill/>
+                </a:ln>
+                <a:solidFill>
+                  <a:schemeClr val="tx1"/>
+                </a:solidFill>
+                <a:effectLst/>
+                <a:latin typeface="Arial" panose="020B0604020202020204" pitchFamily="34" charset="0"/>
+              </a:rPr>
+              <a:t>.</a:t>
+            </a:r>
+          </a:p>
+        </p:txBody>
+      </p:sp>
+    </p:spTree>
+    <p:extLst>
+      <p:ext uri="{BB962C8B-B14F-4D97-AF65-F5344CB8AC3E}">
+        <p14:creationId xmlns:p14="http://schemas.microsoft.com/office/powerpoint/2010/main" val="592592602"/>
+      </p:ext>
+    </p:extLst>
+  </p:cSld>
+  <p:clrMapOvr>
+    <a:masterClrMapping/>
+  </p:clrMapOvr>
+</p:sld>
+</file>
+
+<file path=ppt/slides/slide9.xml><?xml version="1.0" encoding="utf-8"?>
+<p:sld xmlns:a="http://schemas.openxmlformats.org/drawingml/2006/main" xmlns:r="http://schemas.openxmlformats.org/officeDocument/2006/relationships" xmlns:p="http://schemas.openxmlformats.org/presentationml/2006/main">
+  <p:cSld>
+    <p:spTree>
+      <p:nvGrpSpPr>
+        <p:cNvPr id="1" name="">
+          <a:extLst>
+            <a:ext uri="{FF2B5EF4-FFF2-40B4-BE49-F238E27FC236}">
+              <a16:creationId xmlns:a16="http://schemas.microsoft.com/office/drawing/2014/main" id="{D9C63CFA-1082-4A5D-E7B4-9E460C8B460A}"/>
+            </a:ext>
+          </a:extLst>
+        </p:cNvPr>
+        <p:cNvGrpSpPr/>
+        <p:nvPr/>
+      </p:nvGrpSpPr>
+      <p:grpSpPr>
+        <a:xfrm>
+          <a:off x="0" y="0"/>
+          <a:ext cx="0" cy="0"/>
+          <a:chOff x="0" y="0"/>
+          <a:chExt cx="0" cy="0"/>
+        </a:xfrm>
+      </p:grpSpPr>
+      <p:sp>
+        <p:nvSpPr>
+          <p:cNvPr id="3" name="TextBox 2">
+            <a:extLst>
+              <a:ext uri="{FF2B5EF4-FFF2-40B4-BE49-F238E27FC236}">
+                <a16:creationId xmlns:a16="http://schemas.microsoft.com/office/drawing/2014/main" id="{919035A3-2463-1B81-F7A0-C0C8A18E52D2}"/>
+              </a:ext>
+            </a:extLst>
+          </p:cNvPr>
+          <p:cNvSpPr txBox="1"/>
+          <p:nvPr/>
+        </p:nvSpPr>
+        <p:spPr>
+          <a:xfrm>
+            <a:off x="217714" y="255046"/>
+            <a:ext cx="11756571" cy="355354"/>
+          </a:xfrm>
+          <a:prstGeom prst="rect">
+            <a:avLst/>
+          </a:prstGeom>
+          <a:noFill/>
+        </p:spPr>
+        <p:txBody>
+          <a:bodyPr wrap="square">
+            <a:spAutoFit/>
+          </a:bodyPr>
+          <a:lstStyle/>
+          <a:p>
+            <a:pPr>
+              <a:lnSpc>
+                <a:spcPct val="150000"/>
+              </a:lnSpc>
+              <a:buNone/>
+            </a:pPr>
+            <a:r>
+              <a:rPr kumimoji="0" lang="en-US" altLang="en-US" sz="1300" b="0" i="0" u="none" strike="noStrike" cap="none" normalizeH="0" baseline="0">
+                <a:ln>
+                  <a:noFill/>
+                </a:ln>
+                <a:solidFill>
+                  <a:schemeClr val="tx1"/>
+                </a:solidFill>
+                <a:effectLst/>
+                <a:latin typeface="Arial" panose="020B0604020202020204" pitchFamily="34" charset="0"/>
+              </a:rPr>
+              <a:t>.</a:t>
+            </a:r>
+          </a:p>
+        </p:txBody>
+      </p:sp>
+    </p:spTree>
+    <p:extLst>
+      <p:ext uri="{BB962C8B-B14F-4D97-AF65-F5344CB8AC3E}">
+        <p14:creationId xmlns:p14="http://schemas.microsoft.com/office/powerpoint/2010/main" val="1966134446"/>
       </p:ext>
     </p:extLst>
   </p:cSld>

</xml_diff>